<commit_message>
Regenerate the Word drafts
These specifications changed, so their renderings were stale:

- schema-registry
- vision
- aas

Rebuilt from 15bf84d7f197.

They are not finalised: the build writes fields, not field results, and
resolving them needs Microsoft Word. Run
pwsh word-drafts/tools/finalize_all.ps1 before merging.

Co-authored-by: Copilot <223556219+Copilot@users.noreply.github.com>
</commit_message>
<xml_diff>
--- a/word-drafts/figures/AAS-Fig10-Composition.pptx
+++ b/word-drafts/figures/AAS-Fig10-Composition.pptx
@@ -3966,7 +3966,7 @@
         <p:spPr>
           <a:xfrm>
             <a:off x="6524625" y="1228725"/>
-            <a:ext cx="485775" cy="123825"/>
+            <a:ext cx="609600" cy="123825"/>
           </a:xfrm>
           <a:prstGeom prst="rect">
             <a:avLst/>
@@ -4038,7 +4038,7 @@
         <p:spPr>
           <a:xfrm>
             <a:off x="7810500" y="1228725"/>
-            <a:ext cx="485775" cy="123825"/>
+            <a:ext cx="609600" cy="123825"/>
           </a:xfrm>
           <a:prstGeom prst="rect">
             <a:avLst/>
@@ -4110,7 +4110,7 @@
         <p:spPr>
           <a:xfrm>
             <a:off x="9096375" y="1228725"/>
-            <a:ext cx="485775" cy="123825"/>
+            <a:ext cx="609600" cy="123825"/>
           </a:xfrm>
           <a:prstGeom prst="rect">
             <a:avLst/>
@@ -4182,7 +4182,7 @@
         <p:spPr>
           <a:xfrm>
             <a:off x="3309937" y="2314575"/>
-            <a:ext cx="619125" cy="123825"/>
+            <a:ext cx="762000" cy="123825"/>
           </a:xfrm>
           <a:prstGeom prst="rect">
             <a:avLst/>
@@ -4254,7 +4254,7 @@
         <p:spPr>
           <a:xfrm>
             <a:off x="5881687" y="2314575"/>
-            <a:ext cx="619125" cy="123825"/>
+            <a:ext cx="762000" cy="123825"/>
           </a:xfrm>
           <a:prstGeom prst="rect">
             <a:avLst/>
@@ -4326,7 +4326,7 @@
         <p:spPr>
           <a:xfrm>
             <a:off x="5881687" y="2457450"/>
-            <a:ext cx="495300" cy="123825"/>
+            <a:ext cx="619125" cy="123825"/>
           </a:xfrm>
           <a:prstGeom prst="rect">
             <a:avLst/>
@@ -4398,7 +4398,7 @@
         <p:spPr>
           <a:xfrm>
             <a:off x="7167562" y="2314575"/>
-            <a:ext cx="495300" cy="123825"/>
+            <a:ext cx="619125" cy="123825"/>
           </a:xfrm>
           <a:prstGeom prst="rect">
             <a:avLst/>
@@ -4470,7 +4470,7 @@
         <p:spPr>
           <a:xfrm>
             <a:off x="8453437" y="2314575"/>
-            <a:ext cx="495300" cy="123825"/>
+            <a:ext cx="619125" cy="123825"/>
           </a:xfrm>
           <a:prstGeom prst="rect">
             <a:avLst/>
@@ -4542,7 +4542,7 @@
         <p:spPr>
           <a:xfrm>
             <a:off x="11025187" y="2314575"/>
-            <a:ext cx="495300" cy="123825"/>
+            <a:ext cx="619125" cy="123825"/>
           </a:xfrm>
           <a:prstGeom prst="rect">
             <a:avLst/>
@@ -4614,7 +4614,7 @@
         <p:spPr>
           <a:xfrm>
             <a:off x="5238750" y="3286125"/>
-            <a:ext cx="495300" cy="123825"/>
+            <a:ext cx="619125" cy="123825"/>
           </a:xfrm>
           <a:prstGeom prst="rect">
             <a:avLst/>
@@ -4686,7 +4686,7 @@
         <p:spPr>
           <a:xfrm>
             <a:off x="6524625" y="3286125"/>
-            <a:ext cx="495300" cy="123825"/>
+            <a:ext cx="619125" cy="123825"/>
           </a:xfrm>
           <a:prstGeom prst="rect">
             <a:avLst/>
@@ -4758,7 +4758,7 @@
         <p:spPr>
           <a:xfrm>
             <a:off x="9096375" y="3286125"/>
-            <a:ext cx="495300" cy="123825"/>
+            <a:ext cx="619125" cy="123825"/>
           </a:xfrm>
           <a:prstGeom prst="rect">
             <a:avLst/>
@@ -4830,7 +4830,7 @@
         <p:spPr>
           <a:xfrm>
             <a:off x="10382250" y="3286125"/>
-            <a:ext cx="495300" cy="123825"/>
+            <a:ext cx="619125" cy="123825"/>
           </a:xfrm>
           <a:prstGeom prst="rect">
             <a:avLst/>
@@ -4902,7 +4902,7 @@
         <p:spPr>
           <a:xfrm>
             <a:off x="11668125" y="3286125"/>
-            <a:ext cx="495300" cy="123825"/>
+            <a:ext cx="619125" cy="123825"/>
           </a:xfrm>
           <a:prstGeom prst="rect">
             <a:avLst/>

</xml_diff>